<commit_message>
results: update combined fusion results with corrected augmentation (job 1489995)
Key changes vs previous combined run (Aug 14, old augmentation):
- Image component now uses corrected aug (fill=[178,178,178], ForegroundColorJitter)
- Dy24 image BA in combined run: matches standalone 0.853 (vs old 0.581)
- Best fusion at Dy30: Morph+Img mean=0.896, 3-model mean=0.890 (unchanged)
- Met+Img now competitive at mid-days due to stronger image signal

Updated:
- figures/combined_kfold_two_panel_series_idor.png — regenerated
- figures/combined_kfold_table_series_idor.png — regenerated
- figures/multimodel_summary.pptx — added image + combined fusion slides
- notes/combined_model.md — updated fusion tables with OOF results
- update_combined_results.py — fixed JSON key names (met+morph_mean_prob etc.)
- gradcam_demo.py — fix IndexError on scalar prob variable

Co-Authored-By: Claude Sonnet 4.6 <noreply@anthropic.com>
</commit_message>
<xml_diff>
--- a/figures/multimodel_summary.pptx
+++ b/figures/multimodel_summary.pptx
@@ -9,6 +9,8 @@
     <p:sldId id="257" r:id="rId8"/>
     <p:sldId id="258" r:id="rId9"/>
     <p:sldId id="259" r:id="rId10"/>
+    <p:sldId id="260" r:id="rId11"/>
+    <p:sldId id="261" r:id="rId12"/>
   </p:sldIdLst>
   <p:sldSz cx="12188952" cy="6858000" type="screen4x3"/>
   <p:notesSz cx="6858000" cy="9144000"/>
@@ -3197,7 +3199,7 @@
                   <a:srgbClr val="BBCCFF"/>
                 </a:solidFill>
               </a:rPr>
-              <a:t>Metabolite  ·  Morphology  |  5-fold stratified CV, threshold 0.5</a:t>
+              <a:t>Metabolite · Morphology · Image  |  5-fold stratified CV, threshold 0.5</a:t>
             </a:r>
           </a:p>
         </p:txBody>
@@ -3768,7 +3770,7 @@
                   <a:srgbClr val="BBCCFF"/>
                 </a:solidFill>
               </a:rPr>
-              <a:t>Mean ± Std  (5-fold CV)  |  LightGBM shown in bold</a:t>
+              <a:t>Mean ± Std  (5-fold CV)  |  Image from corrected-aug run (job 1459514);  Combined from job 1489995</a:t>
             </a:r>
           </a:p>
         </p:txBody>
@@ -4833,7 +4835,7 @@
                   <a:srgbClr val="2CA02C"/>
                 </a:solidFill>
               </a:rPr>
-              <a:t>0.601 ± 0.101</a:t>
+              <a:t>0.511±0.022</a:t>
             </a:r>
           </a:p>
         </p:txBody>
@@ -4910,7 +4912,7 @@
                   <a:srgbClr val="555555"/>
                 </a:solidFill>
               </a:rPr>
-              <a:t>Dy13</a:t>
+              <a:t>0.527</a:t>
             </a:r>
           </a:p>
         </p:txBody>
@@ -5549,7 +5551,7 @@
                   <a:srgbClr val="555555"/>
                 </a:solidFill>
               </a:rPr>
-              <a:t>Dy20_5</a:t>
+              <a:t>0.500±0.000</a:t>
             </a:r>
           </a:p>
         </p:txBody>
@@ -5617,7 +5619,7 @@
                   <a:srgbClr val="1F77B4"/>
                 </a:solidFill>
               </a:rPr>
-              <a:t>0.788 ± 0.144</a:t>
+              <a:t>0.509</a:t>
             </a:r>
           </a:p>
         </p:txBody>
@@ -6256,7 +6258,7 @@
                   <a:srgbClr val="1F77B4"/>
                 </a:solidFill>
               </a:rPr>
-              <a:t>0.799 ± 0.041</a:t>
+              <a:t>0.500±0.000</a:t>
             </a:r>
           </a:p>
         </p:txBody>
@@ -6324,7 +6326,7 @@
                   <a:srgbClr val="2CA02C"/>
                 </a:solidFill>
               </a:rPr>
-              <a:t>0.496 ± 0.062</a:t>
+              <a:t>0.532</a:t>
             </a:r>
           </a:p>
         </p:txBody>
@@ -6363,6 +6365,206 @@
           </a:p>
         </p:txBody>
       </p:sp>
+    </p:spTree>
+  </p:cSld>
+  <p:clrMapOvr>
+    <a:masterClrMapping/>
+  </p:clrMapOvr>
+</p:sld>
+</file>
+
+<file path=ppt/slides/slide5.xml><?xml version="1.0" encoding="utf-8"?>
+<p:sld xmlns:a="http://schemas.openxmlformats.org/drawingml/2006/main" xmlns:p="http://schemas.openxmlformats.org/presentationml/2006/main" xmlns:r="http://schemas.openxmlformats.org/officeDocument/2006/relationships">
+  <p:cSld>
+    <p:spTree>
+      <p:nvGrpSpPr>
+        <p:cNvPr id="1" name=""/>
+        <p:cNvGrpSpPr/>
+        <p:nvPr/>
+      </p:nvGrpSpPr>
+      <p:grpSpPr/>
+      <p:sp>
+        <p:nvSpPr>
+          <p:cNvPr id="2" name="TextBox 1"/>
+          <p:cNvSpPr txBox="1"/>
+          <p:nvPr/>
+        </p:nvSpPr>
+        <p:spPr>
+          <a:xfrm>
+            <a:off x="274320" y="91440"/>
+            <a:ext cx="10972800" cy="548640"/>
+          </a:xfrm>
+          <a:prstGeom prst="rect">
+            <a:avLst/>
+          </a:prstGeom>
+          <a:noFill/>
+        </p:spPr>
+        <p:txBody>
+          <a:bodyPr wrap="none">
+            <a:spAutoFit/>
+          </a:bodyPr>
+          <a:lstStyle/>
+          <a:p>
+            <a:r>
+              <a:rPr sz="2400" b="1"/>
+              <a:t>Image Classifier — EfficientNet-B0</a:t>
+            </a:r>
+          </a:p>
+        </p:txBody>
+      </p:sp>
+      <p:sp>
+        <p:nvSpPr>
+          <p:cNvPr id="3" name="TextBox 2"/>
+          <p:cNvSpPr txBox="1"/>
+          <p:nvPr/>
+        </p:nvSpPr>
+        <p:spPr>
+          <a:xfrm>
+            <a:off x="274320" y="594360"/>
+            <a:ext cx="10972800" cy="365760"/>
+          </a:xfrm>
+          <a:prstGeom prst="rect">
+            <a:avLst/>
+          </a:prstGeom>
+          <a:noFill/>
+        </p:spPr>
+        <p:txBody>
+          <a:bodyPr wrap="none">
+            <a:spAutoFit/>
+          </a:bodyPr>
+          <a:lstStyle/>
+          <a:p>
+            <a:r>
+              <a:rPr sz="1400"/>
+              <a:t>series_idor · 5-fold CV (corrected augmentation, job 1459514)</a:t>
+            </a:r>
+          </a:p>
+        </p:txBody>
+      </p:sp>
+      <p:pic>
+        <p:nvPicPr>
+          <p:cNvPr id="4" name="Picture 3" descr="image.png"/>
+          <p:cNvPicPr>
+            <a:picLocks noChangeAspect="1"/>
+          </p:cNvPicPr>
+          <p:nvPr/>
+        </p:nvPicPr>
+        <p:blipFill>
+          <a:blip r:embed="rId2"/>
+          <a:stretch>
+            <a:fillRect/>
+          </a:stretch>
+        </p:blipFill>
+        <p:spPr>
+          <a:xfrm>
+            <a:off x="914400" y="1097280"/>
+            <a:ext cx="10058400" cy="5303520"/>
+          </a:xfrm>
+          <a:prstGeom prst="rect">
+            <a:avLst/>
+          </a:prstGeom>
+        </p:spPr>
+      </p:pic>
+    </p:spTree>
+  </p:cSld>
+  <p:clrMapOvr>
+    <a:masterClrMapping/>
+  </p:clrMapOvr>
+</p:sld>
+</file>
+
+<file path=ppt/slides/slide6.xml><?xml version="1.0" encoding="utf-8"?>
+<p:sld xmlns:a="http://schemas.openxmlformats.org/drawingml/2006/main" xmlns:p="http://schemas.openxmlformats.org/presentationml/2006/main" xmlns:r="http://schemas.openxmlformats.org/officeDocument/2006/relationships">
+  <p:cSld>
+    <p:spTree>
+      <p:nvGrpSpPr>
+        <p:cNvPr id="1" name=""/>
+        <p:cNvGrpSpPr/>
+        <p:nvPr/>
+      </p:nvGrpSpPr>
+      <p:grpSpPr/>
+      <p:sp>
+        <p:nvSpPr>
+          <p:cNvPr id="2" name="TextBox 1"/>
+          <p:cNvSpPr txBox="1"/>
+          <p:nvPr/>
+        </p:nvSpPr>
+        <p:spPr>
+          <a:xfrm>
+            <a:off x="274320" y="91440"/>
+            <a:ext cx="10972800" cy="548640"/>
+          </a:xfrm>
+          <a:prstGeom prst="rect">
+            <a:avLst/>
+          </a:prstGeom>
+          <a:noFill/>
+        </p:spPr>
+        <p:txBody>
+          <a:bodyPr wrap="none">
+            <a:spAutoFit/>
+          </a:bodyPr>
+          <a:lstStyle/>
+          <a:p>
+            <a:r>
+              <a:rPr sz="2400" b="1"/>
+              <a:t>Multi-Modality Fusion — Balanced Accuracy by Day</a:t>
+            </a:r>
+          </a:p>
+        </p:txBody>
+      </p:sp>
+      <p:sp>
+        <p:nvSpPr>
+          <p:cNvPr id="3" name="TextBox 2"/>
+          <p:cNvSpPr txBox="1"/>
+          <p:nvPr/>
+        </p:nvSpPr>
+        <p:spPr>
+          <a:xfrm>
+            <a:off x="274320" y="594360"/>
+            <a:ext cx="10972800" cy="365760"/>
+          </a:xfrm>
+          <a:prstGeom prst="rect">
+            <a:avLst/>
+          </a:prstGeom>
+          <a:noFill/>
+        </p:spPr>
+        <p:txBody>
+          <a:bodyPr wrap="none">
+            <a:spAutoFit/>
+          </a:bodyPr>
+          <a:lstStyle/>
+          <a:p>
+            <a:r>
+              <a:rPr sz="1400"/>
+              <a:t>Left: single modalities  ·  Right: late-fusion combinations  ·  ±1 SD shading</a:t>
+            </a:r>
+          </a:p>
+        </p:txBody>
+      </p:sp>
+      <p:pic>
+        <p:nvPicPr>
+          <p:cNvPr id="4" name="Picture 3" descr="image.png"/>
+          <p:cNvPicPr>
+            <a:picLocks noChangeAspect="1"/>
+          </p:cNvPicPr>
+          <p:nvPr/>
+        </p:nvPicPr>
+        <p:blipFill>
+          <a:blip r:embed="rId2"/>
+          <a:stretch>
+            <a:fillRect/>
+          </a:stretch>
+        </p:blipFill>
+        <p:spPr>
+          <a:xfrm>
+            <a:off x="457200" y="1097280"/>
+            <a:ext cx="11430000" cy="5303520"/>
+          </a:xfrm>
+          <a:prstGeom prst="rect">
+            <a:avLst/>
+          </a:prstGeom>
+        </p:spPr>
+      </p:pic>
     </p:spTree>
   </p:cSld>
   <p:clrMapOvr>

</xml_diff>